<commit_message>
Apply cost-based Gantt logic to remaining FPSO Bravo items
"UWILD - Amarra profunda" and "Reparo e Retorno de Itens de Mecânica"
had no POB Qtd logged in any month (previously showing "sem cronograma
informado"), but do have Serviço+Material costs. Switched them to the
same [custo] mode already used for similar items, giving all 10 FPSO
Bravo scopes a determinable bar.
</commit_message>
<xml_diff>
--- a/PRIO_Gantt_Top10_OPEX_2027.pptx
+++ b/PRIO_Gantt_Top10_OPEX_2027.pptx
@@ -22084,326 +22084,323 @@
               </a:rPr>
               <a:t>  US$ 620,0 mil</a:t>
             </a:r>
-            <a:endParaRPr lang="en-US" sz="950" dirty="0"/>
-          </a:p>
-        </p:txBody>
-      </p:sp>
-      <p:sp>
-        <p:nvSpPr>
-          <p:cNvPr id="104" name="Shape 102"/>
-          <p:cNvSpPr/>
-          <p:nvPr/>
-        </p:nvSpPr>
-        <p:spPr>
-          <a:xfrm>
-            <a:off x="3657600" y="4279392"/>
-            <a:ext cx="8046720" cy="438912"/>
-          </a:xfrm>
-          <a:prstGeom prst="rect">
-            <a:avLst/>
-          </a:prstGeom>
-          <a:solidFill>
-            <a:srgbClr val="FFFFFF"/>
-          </a:solidFill>
-          <a:ln w="6350">
-            <a:solidFill>
-              <a:srgbClr val="E3E8E9"/>
-            </a:solidFill>
-            <a:prstDash val="solid"/>
-          </a:ln>
-        </p:spPr>
-      </p:sp>
-      <p:sp>
-        <p:nvSpPr>
-          <p:cNvPr id="105" name="Shape 103"/>
-          <p:cNvSpPr/>
-          <p:nvPr/>
-        </p:nvSpPr>
-        <p:spPr>
-          <a:xfrm>
-            <a:off x="4328160" y="4279392"/>
-            <a:ext cx="0" cy="438912"/>
-          </a:xfrm>
-          <a:prstGeom prst="line">
-            <a:avLst/>
-          </a:prstGeom>
-          <a:noFill/>
-          <a:ln w="6350">
-            <a:solidFill>
-              <a:srgbClr val="E3E8E9"/>
-            </a:solidFill>
-            <a:prstDash val="solid"/>
-          </a:ln>
-        </p:spPr>
-      </p:sp>
-      <p:sp>
-        <p:nvSpPr>
-          <p:cNvPr id="106" name="Shape 104"/>
-          <p:cNvSpPr/>
-          <p:nvPr/>
-        </p:nvSpPr>
-        <p:spPr>
-          <a:xfrm>
-            <a:off x="4998720" y="4279392"/>
-            <a:ext cx="0" cy="438912"/>
-          </a:xfrm>
-          <a:prstGeom prst="line">
-            <a:avLst/>
-          </a:prstGeom>
-          <a:noFill/>
-          <a:ln w="6350">
-            <a:solidFill>
-              <a:srgbClr val="E3E8E9"/>
-            </a:solidFill>
-            <a:prstDash val="solid"/>
-          </a:ln>
-        </p:spPr>
-      </p:sp>
-      <p:sp>
-        <p:nvSpPr>
-          <p:cNvPr id="107" name="Shape 105"/>
-          <p:cNvSpPr/>
-          <p:nvPr/>
-        </p:nvSpPr>
-        <p:spPr>
-          <a:xfrm>
-            <a:off x="5669280" y="4279392"/>
-            <a:ext cx="0" cy="438912"/>
-          </a:xfrm>
-          <a:prstGeom prst="line">
-            <a:avLst/>
-          </a:prstGeom>
-          <a:noFill/>
-          <a:ln w="6350">
-            <a:solidFill>
-              <a:srgbClr val="E3E8E9"/>
-            </a:solidFill>
-            <a:prstDash val="solid"/>
-          </a:ln>
-        </p:spPr>
-      </p:sp>
-      <p:sp>
-        <p:nvSpPr>
-          <p:cNvPr id="108" name="Shape 106"/>
-          <p:cNvSpPr/>
-          <p:nvPr/>
-        </p:nvSpPr>
-        <p:spPr>
-          <a:xfrm>
-            <a:off x="6339840" y="4279392"/>
-            <a:ext cx="0" cy="438912"/>
-          </a:xfrm>
-          <a:prstGeom prst="line">
-            <a:avLst/>
-          </a:prstGeom>
-          <a:noFill/>
-          <a:ln w="6350">
-            <a:solidFill>
-              <a:srgbClr val="E3E8E9"/>
-            </a:solidFill>
-            <a:prstDash val="solid"/>
-          </a:ln>
-        </p:spPr>
-      </p:sp>
-      <p:sp>
-        <p:nvSpPr>
-          <p:cNvPr id="109" name="Shape 107"/>
-          <p:cNvSpPr/>
-          <p:nvPr/>
-        </p:nvSpPr>
-        <p:spPr>
-          <a:xfrm>
-            <a:off x="7010400" y="4279392"/>
-            <a:ext cx="0" cy="438912"/>
-          </a:xfrm>
-          <a:prstGeom prst="line">
-            <a:avLst/>
-          </a:prstGeom>
-          <a:noFill/>
-          <a:ln w="6350">
-            <a:solidFill>
-              <a:srgbClr val="E3E8E9"/>
-            </a:solidFill>
-            <a:prstDash val="solid"/>
-          </a:ln>
-        </p:spPr>
-      </p:sp>
-      <p:sp>
-        <p:nvSpPr>
-          <p:cNvPr id="110" name="Shape 108"/>
-          <p:cNvSpPr/>
-          <p:nvPr/>
-        </p:nvSpPr>
-        <p:spPr>
-          <a:xfrm>
-            <a:off x="7680960" y="4279392"/>
-            <a:ext cx="0" cy="438912"/>
-          </a:xfrm>
-          <a:prstGeom prst="line">
-            <a:avLst/>
-          </a:prstGeom>
-          <a:noFill/>
-          <a:ln w="6350">
-            <a:solidFill>
-              <a:srgbClr val="E3E8E9"/>
-            </a:solidFill>
-            <a:prstDash val="solid"/>
-          </a:ln>
-        </p:spPr>
-      </p:sp>
-      <p:sp>
-        <p:nvSpPr>
-          <p:cNvPr id="111" name="Shape 109"/>
-          <p:cNvSpPr/>
-          <p:nvPr/>
-        </p:nvSpPr>
-        <p:spPr>
-          <a:xfrm>
-            <a:off x="8351520" y="4279392"/>
-            <a:ext cx="0" cy="438912"/>
-          </a:xfrm>
-          <a:prstGeom prst="line">
-            <a:avLst/>
-          </a:prstGeom>
-          <a:noFill/>
-          <a:ln w="6350">
-            <a:solidFill>
-              <a:srgbClr val="E3E8E9"/>
-            </a:solidFill>
-            <a:prstDash val="solid"/>
-          </a:ln>
-        </p:spPr>
-      </p:sp>
-      <p:sp>
-        <p:nvSpPr>
-          <p:cNvPr id="112" name="Shape 110"/>
-          <p:cNvSpPr/>
-          <p:nvPr/>
-        </p:nvSpPr>
-        <p:spPr>
-          <a:xfrm>
-            <a:off x="9022080" y="4279392"/>
-            <a:ext cx="0" cy="438912"/>
-          </a:xfrm>
-          <a:prstGeom prst="line">
-            <a:avLst/>
-          </a:prstGeom>
-          <a:noFill/>
-          <a:ln w="6350">
-            <a:solidFill>
-              <a:srgbClr val="E3E8E9"/>
-            </a:solidFill>
-            <a:prstDash val="solid"/>
-          </a:ln>
-        </p:spPr>
-      </p:sp>
-      <p:sp>
-        <p:nvSpPr>
-          <p:cNvPr id="113" name="Shape 111"/>
-          <p:cNvSpPr/>
-          <p:nvPr/>
-        </p:nvSpPr>
-        <p:spPr>
-          <a:xfrm>
-            <a:off x="9692640" y="4279392"/>
-            <a:ext cx="0" cy="438912"/>
-          </a:xfrm>
-          <a:prstGeom prst="line">
-            <a:avLst/>
-          </a:prstGeom>
-          <a:noFill/>
-          <a:ln w="6350">
-            <a:solidFill>
-              <a:srgbClr val="E3E8E9"/>
-            </a:solidFill>
-            <a:prstDash val="solid"/>
-          </a:ln>
-        </p:spPr>
-      </p:sp>
-      <p:sp>
-        <p:nvSpPr>
-          <p:cNvPr id="114" name="Shape 112"/>
-          <p:cNvSpPr/>
-          <p:nvPr/>
-        </p:nvSpPr>
-        <p:spPr>
-          <a:xfrm>
-            <a:off x="10363200" y="4279392"/>
-            <a:ext cx="0" cy="438912"/>
-          </a:xfrm>
-          <a:prstGeom prst="line">
-            <a:avLst/>
-          </a:prstGeom>
-          <a:noFill/>
-          <a:ln w="6350">
-            <a:solidFill>
-              <a:srgbClr val="E3E8E9"/>
-            </a:solidFill>
-            <a:prstDash val="solid"/>
-          </a:ln>
-        </p:spPr>
-      </p:sp>
-      <p:sp>
-        <p:nvSpPr>
-          <p:cNvPr id="115" name="Shape 113"/>
-          <p:cNvSpPr/>
-          <p:nvPr/>
-        </p:nvSpPr>
-        <p:spPr>
-          <a:xfrm>
-            <a:off x="11033760" y="4279392"/>
-            <a:ext cx="0" cy="438912"/>
-          </a:xfrm>
-          <a:prstGeom prst="line">
-            <a:avLst/>
-          </a:prstGeom>
-          <a:noFill/>
-          <a:ln w="6350">
-            <a:solidFill>
-              <a:srgbClr val="E3E8E9"/>
-            </a:solidFill>
-            <a:prstDash val="solid"/>
-          </a:ln>
-        </p:spPr>
-      </p:sp>
-      <p:sp>
-        <p:nvSpPr>
-          <p:cNvPr id="116" name="Text 114"/>
-          <p:cNvSpPr txBox="1"/>
-          <p:nvPr/>
-        </p:nvSpPr>
-        <p:spPr>
-          <a:xfrm>
-            <a:off x="3657600" y="4279392"/>
-            <a:ext cx="8046720" cy="438912"/>
-          </a:xfrm>
-          <a:prstGeom prst="rect">
-            <a:avLst/>
-          </a:prstGeom>
-          <a:noFill/>
-          <a:ln/>
-        </p:spPr>
-        <p:txBody>
-          <a:bodyPr wrap="square" lIns="0" tIns="0" rIns="0" bIns="0" rtlCol="0" anchor="ctr"/>
-          <a:lstStyle/>
-          <a:p>
-            <a:pPr algn="ctr" indent="0" marL="0">
+            <a:pPr indent="0" marL="0">
               <a:buNone/>
             </a:pPr>
             <a:r>
-              <a:rPr lang="en-US" sz="850" i="1" dirty="0">
+              <a:rPr lang="en-US" sz="750" i="1" dirty="0">
                 <a:solidFill>
-                  <a:srgbClr val="8A979D"/>
+                  <a:srgbClr val="5B6B73"/>
                 </a:solidFill>
                 <a:latin typeface="Calibri" pitchFamily="34" charset="0"/>
                 <a:ea typeface="Calibri" pitchFamily="34" charset="-122"/>
                 <a:cs typeface="Calibri" pitchFamily="34" charset="-120"/>
               </a:rPr>
-              <a:t>sem cronograma informado</a:t>
+              <a:t>  [custo]</a:t>
             </a:r>
-            <a:endParaRPr lang="en-US" sz="850" dirty="0"/>
+            <a:endParaRPr lang="en-US" sz="950" dirty="0"/>
           </a:p>
         </p:txBody>
+      </p:sp>
+      <p:sp>
+        <p:nvSpPr>
+          <p:cNvPr id="104" name="Shape 102"/>
+          <p:cNvSpPr/>
+          <p:nvPr/>
+        </p:nvSpPr>
+        <p:spPr>
+          <a:xfrm>
+            <a:off x="3657600" y="4279392"/>
+            <a:ext cx="8046720" cy="438912"/>
+          </a:xfrm>
+          <a:prstGeom prst="rect">
+            <a:avLst/>
+          </a:prstGeom>
+          <a:solidFill>
+            <a:srgbClr val="FFFFFF"/>
+          </a:solidFill>
+          <a:ln w="6350">
+            <a:solidFill>
+              <a:srgbClr val="E3E8E9"/>
+            </a:solidFill>
+            <a:prstDash val="solid"/>
+          </a:ln>
+        </p:spPr>
+      </p:sp>
+      <p:sp>
+        <p:nvSpPr>
+          <p:cNvPr id="105" name="Shape 103"/>
+          <p:cNvSpPr/>
+          <p:nvPr/>
+        </p:nvSpPr>
+        <p:spPr>
+          <a:xfrm>
+            <a:off x="4328160" y="4279392"/>
+            <a:ext cx="0" cy="438912"/>
+          </a:xfrm>
+          <a:prstGeom prst="line">
+            <a:avLst/>
+          </a:prstGeom>
+          <a:noFill/>
+          <a:ln w="6350">
+            <a:solidFill>
+              <a:srgbClr val="E3E8E9"/>
+            </a:solidFill>
+            <a:prstDash val="solid"/>
+          </a:ln>
+        </p:spPr>
+      </p:sp>
+      <p:sp>
+        <p:nvSpPr>
+          <p:cNvPr id="106" name="Shape 104"/>
+          <p:cNvSpPr/>
+          <p:nvPr/>
+        </p:nvSpPr>
+        <p:spPr>
+          <a:xfrm>
+            <a:off x="4998720" y="4279392"/>
+            <a:ext cx="0" cy="438912"/>
+          </a:xfrm>
+          <a:prstGeom prst="line">
+            <a:avLst/>
+          </a:prstGeom>
+          <a:noFill/>
+          <a:ln w="6350">
+            <a:solidFill>
+              <a:srgbClr val="E3E8E9"/>
+            </a:solidFill>
+            <a:prstDash val="solid"/>
+          </a:ln>
+        </p:spPr>
+      </p:sp>
+      <p:sp>
+        <p:nvSpPr>
+          <p:cNvPr id="107" name="Shape 105"/>
+          <p:cNvSpPr/>
+          <p:nvPr/>
+        </p:nvSpPr>
+        <p:spPr>
+          <a:xfrm>
+            <a:off x="5669280" y="4279392"/>
+            <a:ext cx="0" cy="438912"/>
+          </a:xfrm>
+          <a:prstGeom prst="line">
+            <a:avLst/>
+          </a:prstGeom>
+          <a:noFill/>
+          <a:ln w="6350">
+            <a:solidFill>
+              <a:srgbClr val="E3E8E9"/>
+            </a:solidFill>
+            <a:prstDash val="solid"/>
+          </a:ln>
+        </p:spPr>
+      </p:sp>
+      <p:sp>
+        <p:nvSpPr>
+          <p:cNvPr id="108" name="Shape 106"/>
+          <p:cNvSpPr/>
+          <p:nvPr/>
+        </p:nvSpPr>
+        <p:spPr>
+          <a:xfrm>
+            <a:off x="6339840" y="4279392"/>
+            <a:ext cx="0" cy="438912"/>
+          </a:xfrm>
+          <a:prstGeom prst="line">
+            <a:avLst/>
+          </a:prstGeom>
+          <a:noFill/>
+          <a:ln w="6350">
+            <a:solidFill>
+              <a:srgbClr val="E3E8E9"/>
+            </a:solidFill>
+            <a:prstDash val="solid"/>
+          </a:ln>
+        </p:spPr>
+      </p:sp>
+      <p:sp>
+        <p:nvSpPr>
+          <p:cNvPr id="109" name="Shape 107"/>
+          <p:cNvSpPr/>
+          <p:nvPr/>
+        </p:nvSpPr>
+        <p:spPr>
+          <a:xfrm>
+            <a:off x="7010400" y="4279392"/>
+            <a:ext cx="0" cy="438912"/>
+          </a:xfrm>
+          <a:prstGeom prst="line">
+            <a:avLst/>
+          </a:prstGeom>
+          <a:noFill/>
+          <a:ln w="6350">
+            <a:solidFill>
+              <a:srgbClr val="E3E8E9"/>
+            </a:solidFill>
+            <a:prstDash val="solid"/>
+          </a:ln>
+        </p:spPr>
+      </p:sp>
+      <p:sp>
+        <p:nvSpPr>
+          <p:cNvPr id="110" name="Shape 108"/>
+          <p:cNvSpPr/>
+          <p:nvPr/>
+        </p:nvSpPr>
+        <p:spPr>
+          <a:xfrm>
+            <a:off x="7680960" y="4279392"/>
+            <a:ext cx="0" cy="438912"/>
+          </a:xfrm>
+          <a:prstGeom prst="line">
+            <a:avLst/>
+          </a:prstGeom>
+          <a:noFill/>
+          <a:ln w="6350">
+            <a:solidFill>
+              <a:srgbClr val="E3E8E9"/>
+            </a:solidFill>
+            <a:prstDash val="solid"/>
+          </a:ln>
+        </p:spPr>
+      </p:sp>
+      <p:sp>
+        <p:nvSpPr>
+          <p:cNvPr id="111" name="Shape 109"/>
+          <p:cNvSpPr/>
+          <p:nvPr/>
+        </p:nvSpPr>
+        <p:spPr>
+          <a:xfrm>
+            <a:off x="8351520" y="4279392"/>
+            <a:ext cx="0" cy="438912"/>
+          </a:xfrm>
+          <a:prstGeom prst="line">
+            <a:avLst/>
+          </a:prstGeom>
+          <a:noFill/>
+          <a:ln w="6350">
+            <a:solidFill>
+              <a:srgbClr val="E3E8E9"/>
+            </a:solidFill>
+            <a:prstDash val="solid"/>
+          </a:ln>
+        </p:spPr>
+      </p:sp>
+      <p:sp>
+        <p:nvSpPr>
+          <p:cNvPr id="112" name="Shape 110"/>
+          <p:cNvSpPr/>
+          <p:nvPr/>
+        </p:nvSpPr>
+        <p:spPr>
+          <a:xfrm>
+            <a:off x="9022080" y="4279392"/>
+            <a:ext cx="0" cy="438912"/>
+          </a:xfrm>
+          <a:prstGeom prst="line">
+            <a:avLst/>
+          </a:prstGeom>
+          <a:noFill/>
+          <a:ln w="6350">
+            <a:solidFill>
+              <a:srgbClr val="E3E8E9"/>
+            </a:solidFill>
+            <a:prstDash val="solid"/>
+          </a:ln>
+        </p:spPr>
+      </p:sp>
+      <p:sp>
+        <p:nvSpPr>
+          <p:cNvPr id="113" name="Shape 111"/>
+          <p:cNvSpPr/>
+          <p:nvPr/>
+        </p:nvSpPr>
+        <p:spPr>
+          <a:xfrm>
+            <a:off x="9692640" y="4279392"/>
+            <a:ext cx="0" cy="438912"/>
+          </a:xfrm>
+          <a:prstGeom prst="line">
+            <a:avLst/>
+          </a:prstGeom>
+          <a:noFill/>
+          <a:ln w="6350">
+            <a:solidFill>
+              <a:srgbClr val="E3E8E9"/>
+            </a:solidFill>
+            <a:prstDash val="solid"/>
+          </a:ln>
+        </p:spPr>
+      </p:sp>
+      <p:sp>
+        <p:nvSpPr>
+          <p:cNvPr id="114" name="Shape 112"/>
+          <p:cNvSpPr/>
+          <p:nvPr/>
+        </p:nvSpPr>
+        <p:spPr>
+          <a:xfrm>
+            <a:off x="10363200" y="4279392"/>
+            <a:ext cx="0" cy="438912"/>
+          </a:xfrm>
+          <a:prstGeom prst="line">
+            <a:avLst/>
+          </a:prstGeom>
+          <a:noFill/>
+          <a:ln w="6350">
+            <a:solidFill>
+              <a:srgbClr val="E3E8E9"/>
+            </a:solidFill>
+            <a:prstDash val="solid"/>
+          </a:ln>
+        </p:spPr>
+      </p:sp>
+      <p:sp>
+        <p:nvSpPr>
+          <p:cNvPr id="115" name="Shape 113"/>
+          <p:cNvSpPr/>
+          <p:nvPr/>
+        </p:nvSpPr>
+        <p:spPr>
+          <a:xfrm>
+            <a:off x="11033760" y="4279392"/>
+            <a:ext cx="0" cy="438912"/>
+          </a:xfrm>
+          <a:prstGeom prst="line">
+            <a:avLst/>
+          </a:prstGeom>
+          <a:noFill/>
+          <a:ln w="6350">
+            <a:solidFill>
+              <a:srgbClr val="E3E8E9"/>
+            </a:solidFill>
+            <a:prstDash val="solid"/>
+          </a:ln>
+        </p:spPr>
+      </p:sp>
+      <p:sp>
+        <p:nvSpPr>
+          <p:cNvPr id="116" name="Shape 114"/>
+          <p:cNvSpPr/>
+          <p:nvPr/>
+        </p:nvSpPr>
+        <p:spPr>
+          <a:xfrm>
+            <a:off x="4355592" y="4361688"/>
+            <a:ext cx="615696" cy="274320"/>
+          </a:xfrm>
+          <a:prstGeom prst="roundRect">
+            <a:avLst>
+              <a:gd name="adj" fmla="val 13333"/>
+            </a:avLst>
+          </a:prstGeom>
+          <a:solidFill>
+            <a:srgbClr val="8A5A2E"/>
+          </a:solidFill>
+          <a:ln/>
+        </p:spPr>
       </p:sp>
       <p:sp>
         <p:nvSpPr>
@@ -22456,326 +22453,323 @@
               </a:rPr>
               <a:t>  US$ 610,5 mil</a:t>
             </a:r>
-            <a:endParaRPr lang="en-US" sz="950" dirty="0"/>
-          </a:p>
-        </p:txBody>
-      </p:sp>
-      <p:sp>
-        <p:nvSpPr>
-          <p:cNvPr id="118" name="Shape 116"/>
-          <p:cNvSpPr/>
-          <p:nvPr/>
-        </p:nvSpPr>
-        <p:spPr>
-          <a:xfrm>
-            <a:off x="3657600" y="4718304"/>
-            <a:ext cx="8046720" cy="438912"/>
-          </a:xfrm>
-          <a:prstGeom prst="rect">
-            <a:avLst/>
-          </a:prstGeom>
-          <a:solidFill>
-            <a:srgbClr val="F0F4F5"/>
-          </a:solidFill>
-          <a:ln w="6350">
-            <a:solidFill>
-              <a:srgbClr val="E3E8E9"/>
-            </a:solidFill>
-            <a:prstDash val="solid"/>
-          </a:ln>
-        </p:spPr>
-      </p:sp>
-      <p:sp>
-        <p:nvSpPr>
-          <p:cNvPr id="119" name="Shape 117"/>
-          <p:cNvSpPr/>
-          <p:nvPr/>
-        </p:nvSpPr>
-        <p:spPr>
-          <a:xfrm>
-            <a:off x="4328160" y="4718304"/>
-            <a:ext cx="0" cy="438912"/>
-          </a:xfrm>
-          <a:prstGeom prst="line">
-            <a:avLst/>
-          </a:prstGeom>
-          <a:noFill/>
-          <a:ln w="6350">
-            <a:solidFill>
-              <a:srgbClr val="E3E8E9"/>
-            </a:solidFill>
-            <a:prstDash val="solid"/>
-          </a:ln>
-        </p:spPr>
-      </p:sp>
-      <p:sp>
-        <p:nvSpPr>
-          <p:cNvPr id="120" name="Shape 118"/>
-          <p:cNvSpPr/>
-          <p:nvPr/>
-        </p:nvSpPr>
-        <p:spPr>
-          <a:xfrm>
-            <a:off x="4998720" y="4718304"/>
-            <a:ext cx="0" cy="438912"/>
-          </a:xfrm>
-          <a:prstGeom prst="line">
-            <a:avLst/>
-          </a:prstGeom>
-          <a:noFill/>
-          <a:ln w="6350">
-            <a:solidFill>
-              <a:srgbClr val="E3E8E9"/>
-            </a:solidFill>
-            <a:prstDash val="solid"/>
-          </a:ln>
-        </p:spPr>
-      </p:sp>
-      <p:sp>
-        <p:nvSpPr>
-          <p:cNvPr id="121" name="Shape 119"/>
-          <p:cNvSpPr/>
-          <p:nvPr/>
-        </p:nvSpPr>
-        <p:spPr>
-          <a:xfrm>
-            <a:off x="5669280" y="4718304"/>
-            <a:ext cx="0" cy="438912"/>
-          </a:xfrm>
-          <a:prstGeom prst="line">
-            <a:avLst/>
-          </a:prstGeom>
-          <a:noFill/>
-          <a:ln w="6350">
-            <a:solidFill>
-              <a:srgbClr val="E3E8E9"/>
-            </a:solidFill>
-            <a:prstDash val="solid"/>
-          </a:ln>
-        </p:spPr>
-      </p:sp>
-      <p:sp>
-        <p:nvSpPr>
-          <p:cNvPr id="122" name="Shape 120"/>
-          <p:cNvSpPr/>
-          <p:nvPr/>
-        </p:nvSpPr>
-        <p:spPr>
-          <a:xfrm>
-            <a:off x="6339840" y="4718304"/>
-            <a:ext cx="0" cy="438912"/>
-          </a:xfrm>
-          <a:prstGeom prst="line">
-            <a:avLst/>
-          </a:prstGeom>
-          <a:noFill/>
-          <a:ln w="6350">
-            <a:solidFill>
-              <a:srgbClr val="E3E8E9"/>
-            </a:solidFill>
-            <a:prstDash val="solid"/>
-          </a:ln>
-        </p:spPr>
-      </p:sp>
-      <p:sp>
-        <p:nvSpPr>
-          <p:cNvPr id="123" name="Shape 121"/>
-          <p:cNvSpPr/>
-          <p:nvPr/>
-        </p:nvSpPr>
-        <p:spPr>
-          <a:xfrm>
-            <a:off x="7010400" y="4718304"/>
-            <a:ext cx="0" cy="438912"/>
-          </a:xfrm>
-          <a:prstGeom prst="line">
-            <a:avLst/>
-          </a:prstGeom>
-          <a:noFill/>
-          <a:ln w="6350">
-            <a:solidFill>
-              <a:srgbClr val="E3E8E9"/>
-            </a:solidFill>
-            <a:prstDash val="solid"/>
-          </a:ln>
-        </p:spPr>
-      </p:sp>
-      <p:sp>
-        <p:nvSpPr>
-          <p:cNvPr id="124" name="Shape 122"/>
-          <p:cNvSpPr/>
-          <p:nvPr/>
-        </p:nvSpPr>
-        <p:spPr>
-          <a:xfrm>
-            <a:off x="7680960" y="4718304"/>
-            <a:ext cx="0" cy="438912"/>
-          </a:xfrm>
-          <a:prstGeom prst="line">
-            <a:avLst/>
-          </a:prstGeom>
-          <a:noFill/>
-          <a:ln w="6350">
-            <a:solidFill>
-              <a:srgbClr val="E3E8E9"/>
-            </a:solidFill>
-            <a:prstDash val="solid"/>
-          </a:ln>
-        </p:spPr>
-      </p:sp>
-      <p:sp>
-        <p:nvSpPr>
-          <p:cNvPr id="125" name="Shape 123"/>
-          <p:cNvSpPr/>
-          <p:nvPr/>
-        </p:nvSpPr>
-        <p:spPr>
-          <a:xfrm>
-            <a:off x="8351520" y="4718304"/>
-            <a:ext cx="0" cy="438912"/>
-          </a:xfrm>
-          <a:prstGeom prst="line">
-            <a:avLst/>
-          </a:prstGeom>
-          <a:noFill/>
-          <a:ln w="6350">
-            <a:solidFill>
-              <a:srgbClr val="E3E8E9"/>
-            </a:solidFill>
-            <a:prstDash val="solid"/>
-          </a:ln>
-        </p:spPr>
-      </p:sp>
-      <p:sp>
-        <p:nvSpPr>
-          <p:cNvPr id="126" name="Shape 124"/>
-          <p:cNvSpPr/>
-          <p:nvPr/>
-        </p:nvSpPr>
-        <p:spPr>
-          <a:xfrm>
-            <a:off x="9022080" y="4718304"/>
-            <a:ext cx="0" cy="438912"/>
-          </a:xfrm>
-          <a:prstGeom prst="line">
-            <a:avLst/>
-          </a:prstGeom>
-          <a:noFill/>
-          <a:ln w="6350">
-            <a:solidFill>
-              <a:srgbClr val="E3E8E9"/>
-            </a:solidFill>
-            <a:prstDash val="solid"/>
-          </a:ln>
-        </p:spPr>
-      </p:sp>
-      <p:sp>
-        <p:nvSpPr>
-          <p:cNvPr id="127" name="Shape 125"/>
-          <p:cNvSpPr/>
-          <p:nvPr/>
-        </p:nvSpPr>
-        <p:spPr>
-          <a:xfrm>
-            <a:off x="9692640" y="4718304"/>
-            <a:ext cx="0" cy="438912"/>
-          </a:xfrm>
-          <a:prstGeom prst="line">
-            <a:avLst/>
-          </a:prstGeom>
-          <a:noFill/>
-          <a:ln w="6350">
-            <a:solidFill>
-              <a:srgbClr val="E3E8E9"/>
-            </a:solidFill>
-            <a:prstDash val="solid"/>
-          </a:ln>
-        </p:spPr>
-      </p:sp>
-      <p:sp>
-        <p:nvSpPr>
-          <p:cNvPr id="128" name="Shape 126"/>
-          <p:cNvSpPr/>
-          <p:nvPr/>
-        </p:nvSpPr>
-        <p:spPr>
-          <a:xfrm>
-            <a:off x="10363200" y="4718304"/>
-            <a:ext cx="0" cy="438912"/>
-          </a:xfrm>
-          <a:prstGeom prst="line">
-            <a:avLst/>
-          </a:prstGeom>
-          <a:noFill/>
-          <a:ln w="6350">
-            <a:solidFill>
-              <a:srgbClr val="E3E8E9"/>
-            </a:solidFill>
-            <a:prstDash val="solid"/>
-          </a:ln>
-        </p:spPr>
-      </p:sp>
-      <p:sp>
-        <p:nvSpPr>
-          <p:cNvPr id="129" name="Shape 127"/>
-          <p:cNvSpPr/>
-          <p:nvPr/>
-        </p:nvSpPr>
-        <p:spPr>
-          <a:xfrm>
-            <a:off x="11033760" y="4718304"/>
-            <a:ext cx="0" cy="438912"/>
-          </a:xfrm>
-          <a:prstGeom prst="line">
-            <a:avLst/>
-          </a:prstGeom>
-          <a:noFill/>
-          <a:ln w="6350">
-            <a:solidFill>
-              <a:srgbClr val="E3E8E9"/>
-            </a:solidFill>
-            <a:prstDash val="solid"/>
-          </a:ln>
-        </p:spPr>
-      </p:sp>
-      <p:sp>
-        <p:nvSpPr>
-          <p:cNvPr id="130" name="Text 128"/>
-          <p:cNvSpPr txBox="1"/>
-          <p:nvPr/>
-        </p:nvSpPr>
-        <p:spPr>
-          <a:xfrm>
-            <a:off x="3657600" y="4718304"/>
-            <a:ext cx="8046720" cy="438912"/>
-          </a:xfrm>
-          <a:prstGeom prst="rect">
-            <a:avLst/>
-          </a:prstGeom>
-          <a:noFill/>
-          <a:ln/>
-        </p:spPr>
-        <p:txBody>
-          <a:bodyPr wrap="square" lIns="0" tIns="0" rIns="0" bIns="0" rtlCol="0" anchor="ctr"/>
-          <a:lstStyle/>
-          <a:p>
-            <a:pPr algn="ctr" indent="0" marL="0">
+            <a:pPr indent="0" marL="0">
               <a:buNone/>
             </a:pPr>
             <a:r>
-              <a:rPr lang="en-US" sz="850" i="1" dirty="0">
+              <a:rPr lang="en-US" sz="750" i="1" dirty="0">
                 <a:solidFill>
-                  <a:srgbClr val="8A979D"/>
+                  <a:srgbClr val="5B6B73"/>
                 </a:solidFill>
                 <a:latin typeface="Calibri" pitchFamily="34" charset="0"/>
                 <a:ea typeface="Calibri" pitchFamily="34" charset="-122"/>
                 <a:cs typeface="Calibri" pitchFamily="34" charset="-120"/>
               </a:rPr>
-              <a:t>sem cronograma informado</a:t>
+              <a:t>  [custo]</a:t>
             </a:r>
-            <a:endParaRPr lang="en-US" sz="850" dirty="0"/>
+            <a:endParaRPr lang="en-US" sz="950" dirty="0"/>
           </a:p>
         </p:txBody>
+      </p:sp>
+      <p:sp>
+        <p:nvSpPr>
+          <p:cNvPr id="118" name="Shape 116"/>
+          <p:cNvSpPr/>
+          <p:nvPr/>
+        </p:nvSpPr>
+        <p:spPr>
+          <a:xfrm>
+            <a:off x="3657600" y="4718304"/>
+            <a:ext cx="8046720" cy="438912"/>
+          </a:xfrm>
+          <a:prstGeom prst="rect">
+            <a:avLst/>
+          </a:prstGeom>
+          <a:solidFill>
+            <a:srgbClr val="F0F4F5"/>
+          </a:solidFill>
+          <a:ln w="6350">
+            <a:solidFill>
+              <a:srgbClr val="E3E8E9"/>
+            </a:solidFill>
+            <a:prstDash val="solid"/>
+          </a:ln>
+        </p:spPr>
+      </p:sp>
+      <p:sp>
+        <p:nvSpPr>
+          <p:cNvPr id="119" name="Shape 117"/>
+          <p:cNvSpPr/>
+          <p:nvPr/>
+        </p:nvSpPr>
+        <p:spPr>
+          <a:xfrm>
+            <a:off x="4328160" y="4718304"/>
+            <a:ext cx="0" cy="438912"/>
+          </a:xfrm>
+          <a:prstGeom prst="line">
+            <a:avLst/>
+          </a:prstGeom>
+          <a:noFill/>
+          <a:ln w="6350">
+            <a:solidFill>
+              <a:srgbClr val="E3E8E9"/>
+            </a:solidFill>
+            <a:prstDash val="solid"/>
+          </a:ln>
+        </p:spPr>
+      </p:sp>
+      <p:sp>
+        <p:nvSpPr>
+          <p:cNvPr id="120" name="Shape 118"/>
+          <p:cNvSpPr/>
+          <p:nvPr/>
+        </p:nvSpPr>
+        <p:spPr>
+          <a:xfrm>
+            <a:off x="4998720" y="4718304"/>
+            <a:ext cx="0" cy="438912"/>
+          </a:xfrm>
+          <a:prstGeom prst="line">
+            <a:avLst/>
+          </a:prstGeom>
+          <a:noFill/>
+          <a:ln w="6350">
+            <a:solidFill>
+              <a:srgbClr val="E3E8E9"/>
+            </a:solidFill>
+            <a:prstDash val="solid"/>
+          </a:ln>
+        </p:spPr>
+      </p:sp>
+      <p:sp>
+        <p:nvSpPr>
+          <p:cNvPr id="121" name="Shape 119"/>
+          <p:cNvSpPr/>
+          <p:nvPr/>
+        </p:nvSpPr>
+        <p:spPr>
+          <a:xfrm>
+            <a:off x="5669280" y="4718304"/>
+            <a:ext cx="0" cy="438912"/>
+          </a:xfrm>
+          <a:prstGeom prst="line">
+            <a:avLst/>
+          </a:prstGeom>
+          <a:noFill/>
+          <a:ln w="6350">
+            <a:solidFill>
+              <a:srgbClr val="E3E8E9"/>
+            </a:solidFill>
+            <a:prstDash val="solid"/>
+          </a:ln>
+        </p:spPr>
+      </p:sp>
+      <p:sp>
+        <p:nvSpPr>
+          <p:cNvPr id="122" name="Shape 120"/>
+          <p:cNvSpPr/>
+          <p:nvPr/>
+        </p:nvSpPr>
+        <p:spPr>
+          <a:xfrm>
+            <a:off x="6339840" y="4718304"/>
+            <a:ext cx="0" cy="438912"/>
+          </a:xfrm>
+          <a:prstGeom prst="line">
+            <a:avLst/>
+          </a:prstGeom>
+          <a:noFill/>
+          <a:ln w="6350">
+            <a:solidFill>
+              <a:srgbClr val="E3E8E9"/>
+            </a:solidFill>
+            <a:prstDash val="solid"/>
+          </a:ln>
+        </p:spPr>
+      </p:sp>
+      <p:sp>
+        <p:nvSpPr>
+          <p:cNvPr id="123" name="Shape 121"/>
+          <p:cNvSpPr/>
+          <p:nvPr/>
+        </p:nvSpPr>
+        <p:spPr>
+          <a:xfrm>
+            <a:off x="7010400" y="4718304"/>
+            <a:ext cx="0" cy="438912"/>
+          </a:xfrm>
+          <a:prstGeom prst="line">
+            <a:avLst/>
+          </a:prstGeom>
+          <a:noFill/>
+          <a:ln w="6350">
+            <a:solidFill>
+              <a:srgbClr val="E3E8E9"/>
+            </a:solidFill>
+            <a:prstDash val="solid"/>
+          </a:ln>
+        </p:spPr>
+      </p:sp>
+      <p:sp>
+        <p:nvSpPr>
+          <p:cNvPr id="124" name="Shape 122"/>
+          <p:cNvSpPr/>
+          <p:nvPr/>
+        </p:nvSpPr>
+        <p:spPr>
+          <a:xfrm>
+            <a:off x="7680960" y="4718304"/>
+            <a:ext cx="0" cy="438912"/>
+          </a:xfrm>
+          <a:prstGeom prst="line">
+            <a:avLst/>
+          </a:prstGeom>
+          <a:noFill/>
+          <a:ln w="6350">
+            <a:solidFill>
+              <a:srgbClr val="E3E8E9"/>
+            </a:solidFill>
+            <a:prstDash val="solid"/>
+          </a:ln>
+        </p:spPr>
+      </p:sp>
+      <p:sp>
+        <p:nvSpPr>
+          <p:cNvPr id="125" name="Shape 123"/>
+          <p:cNvSpPr/>
+          <p:nvPr/>
+        </p:nvSpPr>
+        <p:spPr>
+          <a:xfrm>
+            <a:off x="8351520" y="4718304"/>
+            <a:ext cx="0" cy="438912"/>
+          </a:xfrm>
+          <a:prstGeom prst="line">
+            <a:avLst/>
+          </a:prstGeom>
+          <a:noFill/>
+          <a:ln w="6350">
+            <a:solidFill>
+              <a:srgbClr val="E3E8E9"/>
+            </a:solidFill>
+            <a:prstDash val="solid"/>
+          </a:ln>
+        </p:spPr>
+      </p:sp>
+      <p:sp>
+        <p:nvSpPr>
+          <p:cNvPr id="126" name="Shape 124"/>
+          <p:cNvSpPr/>
+          <p:nvPr/>
+        </p:nvSpPr>
+        <p:spPr>
+          <a:xfrm>
+            <a:off x="9022080" y="4718304"/>
+            <a:ext cx="0" cy="438912"/>
+          </a:xfrm>
+          <a:prstGeom prst="line">
+            <a:avLst/>
+          </a:prstGeom>
+          <a:noFill/>
+          <a:ln w="6350">
+            <a:solidFill>
+              <a:srgbClr val="E3E8E9"/>
+            </a:solidFill>
+            <a:prstDash val="solid"/>
+          </a:ln>
+        </p:spPr>
+      </p:sp>
+      <p:sp>
+        <p:nvSpPr>
+          <p:cNvPr id="127" name="Shape 125"/>
+          <p:cNvSpPr/>
+          <p:nvPr/>
+        </p:nvSpPr>
+        <p:spPr>
+          <a:xfrm>
+            <a:off x="9692640" y="4718304"/>
+            <a:ext cx="0" cy="438912"/>
+          </a:xfrm>
+          <a:prstGeom prst="line">
+            <a:avLst/>
+          </a:prstGeom>
+          <a:noFill/>
+          <a:ln w="6350">
+            <a:solidFill>
+              <a:srgbClr val="E3E8E9"/>
+            </a:solidFill>
+            <a:prstDash val="solid"/>
+          </a:ln>
+        </p:spPr>
+      </p:sp>
+      <p:sp>
+        <p:nvSpPr>
+          <p:cNvPr id="128" name="Shape 126"/>
+          <p:cNvSpPr/>
+          <p:nvPr/>
+        </p:nvSpPr>
+        <p:spPr>
+          <a:xfrm>
+            <a:off x="10363200" y="4718304"/>
+            <a:ext cx="0" cy="438912"/>
+          </a:xfrm>
+          <a:prstGeom prst="line">
+            <a:avLst/>
+          </a:prstGeom>
+          <a:noFill/>
+          <a:ln w="6350">
+            <a:solidFill>
+              <a:srgbClr val="E3E8E9"/>
+            </a:solidFill>
+            <a:prstDash val="solid"/>
+          </a:ln>
+        </p:spPr>
+      </p:sp>
+      <p:sp>
+        <p:nvSpPr>
+          <p:cNvPr id="129" name="Shape 127"/>
+          <p:cNvSpPr/>
+          <p:nvPr/>
+        </p:nvSpPr>
+        <p:spPr>
+          <a:xfrm>
+            <a:off x="11033760" y="4718304"/>
+            <a:ext cx="0" cy="438912"/>
+          </a:xfrm>
+          <a:prstGeom prst="line">
+            <a:avLst/>
+          </a:prstGeom>
+          <a:noFill/>
+          <a:ln w="6350">
+            <a:solidFill>
+              <a:srgbClr val="E3E8E9"/>
+            </a:solidFill>
+            <a:prstDash val="solid"/>
+          </a:ln>
+        </p:spPr>
+      </p:sp>
+      <p:sp>
+        <p:nvSpPr>
+          <p:cNvPr id="130" name="Shape 128"/>
+          <p:cNvSpPr/>
+          <p:nvPr/>
+        </p:nvSpPr>
+        <p:spPr>
+          <a:xfrm>
+            <a:off x="3685032" y="4800600"/>
+            <a:ext cx="615696" cy="274320"/>
+          </a:xfrm>
+          <a:prstGeom prst="roundRect">
+            <a:avLst>
+              <a:gd name="adj" fmla="val 13333"/>
+            </a:avLst>
+          </a:prstGeom>
+          <a:solidFill>
+            <a:srgbClr val="8A5A2E"/>
+          </a:solidFill>
+          <a:ln/>
+        </p:spPr>
       </p:sp>
       <p:sp>
         <p:nvSpPr>

</xml_diff>